<commit_message>
Add at Nuclotron, Patr article and new article publ
</commit_message>
<xml_diff>
--- a/2025/8shape/pics.pptx
+++ b/2025/8shape/pics.pptx
@@ -6,6 +6,7 @@
   </p:sldMasterIdLst>
   <p:sldIdLst>
     <p:sldId id="256" r:id="rId2"/>
+    <p:sldId id="257" r:id="rId3"/>
   </p:sldIdLst>
   <p:sldSz cx="12192000" cy="6858000"/>
   <p:notesSz cx="6858000" cy="9144000"/>
@@ -104,6 +105,11 @@
       </a:defRPr>
     </a:lvl9pPr>
   </p:defaultTextStyle>
+  <p:extLst>
+    <p:ext uri="{EFAFB233-063F-42B5-8137-9DF3F51BA10A}">
+      <p15:sldGuideLst xmlns:p15="http://schemas.microsoft.com/office/powerpoint/2012/main"/>
+    </p:ext>
+  </p:extLst>
 </p:presentation>
 </file>
 
@@ -254,7 +260,7 @@
           <a:p>
             <a:fld id="{FABA7B4C-331F-9845-A9F4-2BE58EEACE7D}" type="datetimeFigureOut">
               <a:rPr lang="ru-RU" smtClean="0"/>
-              <a:t>31.01.2025</a:t>
+              <a:t>02.08.2025</a:t>
             </a:fld>
             <a:endParaRPr lang="ru-RU"/>
           </a:p>
@@ -452,7 +458,7 @@
           <a:p>
             <a:fld id="{FABA7B4C-331F-9845-A9F4-2BE58EEACE7D}" type="datetimeFigureOut">
               <a:rPr lang="ru-RU" smtClean="0"/>
-              <a:t>31.01.2025</a:t>
+              <a:t>02.08.2025</a:t>
             </a:fld>
             <a:endParaRPr lang="ru-RU"/>
           </a:p>
@@ -660,7 +666,7 @@
           <a:p>
             <a:fld id="{FABA7B4C-331F-9845-A9F4-2BE58EEACE7D}" type="datetimeFigureOut">
               <a:rPr lang="ru-RU" smtClean="0"/>
-              <a:t>31.01.2025</a:t>
+              <a:t>02.08.2025</a:t>
             </a:fld>
             <a:endParaRPr lang="ru-RU"/>
           </a:p>
@@ -858,7 +864,7 @@
           <a:p>
             <a:fld id="{FABA7B4C-331F-9845-A9F4-2BE58EEACE7D}" type="datetimeFigureOut">
               <a:rPr lang="ru-RU" smtClean="0"/>
-              <a:t>31.01.2025</a:t>
+              <a:t>02.08.2025</a:t>
             </a:fld>
             <a:endParaRPr lang="ru-RU"/>
           </a:p>
@@ -1133,7 +1139,7 @@
           <a:p>
             <a:fld id="{FABA7B4C-331F-9845-A9F4-2BE58EEACE7D}" type="datetimeFigureOut">
               <a:rPr lang="ru-RU" smtClean="0"/>
-              <a:t>31.01.2025</a:t>
+              <a:t>02.08.2025</a:t>
             </a:fld>
             <a:endParaRPr lang="ru-RU"/>
           </a:p>
@@ -1398,7 +1404,7 @@
           <a:p>
             <a:fld id="{FABA7B4C-331F-9845-A9F4-2BE58EEACE7D}" type="datetimeFigureOut">
               <a:rPr lang="ru-RU" smtClean="0"/>
-              <a:t>31.01.2025</a:t>
+              <a:t>02.08.2025</a:t>
             </a:fld>
             <a:endParaRPr lang="ru-RU"/>
           </a:p>
@@ -1810,7 +1816,7 @@
           <a:p>
             <a:fld id="{FABA7B4C-331F-9845-A9F4-2BE58EEACE7D}" type="datetimeFigureOut">
               <a:rPr lang="ru-RU" smtClean="0"/>
-              <a:t>31.01.2025</a:t>
+              <a:t>02.08.2025</a:t>
             </a:fld>
             <a:endParaRPr lang="ru-RU"/>
           </a:p>
@@ -1951,7 +1957,7 @@
           <a:p>
             <a:fld id="{FABA7B4C-331F-9845-A9F4-2BE58EEACE7D}" type="datetimeFigureOut">
               <a:rPr lang="ru-RU" smtClean="0"/>
-              <a:t>31.01.2025</a:t>
+              <a:t>02.08.2025</a:t>
             </a:fld>
             <a:endParaRPr lang="ru-RU"/>
           </a:p>
@@ -2064,7 +2070,7 @@
           <a:p>
             <a:fld id="{FABA7B4C-331F-9845-A9F4-2BE58EEACE7D}" type="datetimeFigureOut">
               <a:rPr lang="ru-RU" smtClean="0"/>
-              <a:t>31.01.2025</a:t>
+              <a:t>02.08.2025</a:t>
             </a:fld>
             <a:endParaRPr lang="ru-RU"/>
           </a:p>
@@ -2375,7 +2381,7 @@
           <a:p>
             <a:fld id="{FABA7B4C-331F-9845-A9F4-2BE58EEACE7D}" type="datetimeFigureOut">
               <a:rPr lang="ru-RU" smtClean="0"/>
-              <a:t>31.01.2025</a:t>
+              <a:t>02.08.2025</a:t>
             </a:fld>
             <a:endParaRPr lang="ru-RU"/>
           </a:p>
@@ -2663,7 +2669,7 @@
           <a:p>
             <a:fld id="{FABA7B4C-331F-9845-A9F4-2BE58EEACE7D}" type="datetimeFigureOut">
               <a:rPr lang="ru-RU" smtClean="0"/>
-              <a:t>31.01.2025</a:t>
+              <a:t>02.08.2025</a:t>
             </a:fld>
             <a:endParaRPr lang="ru-RU"/>
           </a:p>
@@ -2904,7 +2910,7 @@
           <a:p>
             <a:fld id="{FABA7B4C-331F-9845-A9F4-2BE58EEACE7D}" type="datetimeFigureOut">
               <a:rPr lang="ru-RU" smtClean="0"/>
-              <a:t>31.01.2025</a:t>
+              <a:t>02.08.2025</a:t>
             </a:fld>
             <a:endParaRPr lang="ru-RU"/>
           </a:p>
@@ -4805,10 +4811,2329 @@
           </a:p>
         </p:txBody>
       </p:sp>
+      <p:sp>
+        <p:nvSpPr>
+          <p:cNvPr id="2" name="Прямоугольник 1">
+            <a:extLst>
+              <a:ext uri="{FF2B5EF4-FFF2-40B4-BE49-F238E27FC236}">
+                <a16:creationId xmlns:a16="http://schemas.microsoft.com/office/drawing/2014/main" id="{0A7FADC6-DD7A-9360-9756-211CBA4D11EA}"/>
+              </a:ext>
+            </a:extLst>
+          </p:cNvPr>
+          <p:cNvSpPr/>
+          <p:nvPr/>
+        </p:nvSpPr>
+        <p:spPr>
+          <a:xfrm>
+            <a:off x="1540397" y="3717533"/>
+            <a:ext cx="1080000" cy="540000"/>
+          </a:xfrm>
+          <a:prstGeom prst="rect">
+            <a:avLst/>
+          </a:prstGeom>
+          <a:noFill/>
+          <a:ln>
+            <a:solidFill>
+              <a:schemeClr val="tx1"/>
+            </a:solidFill>
+          </a:ln>
+        </p:spPr>
+        <p:style>
+          <a:lnRef idx="2">
+            <a:schemeClr val="accent1">
+              <a:shade val="15000"/>
+            </a:schemeClr>
+          </a:lnRef>
+          <a:fillRef idx="1">
+            <a:schemeClr val="accent1"/>
+          </a:fillRef>
+          <a:effectRef idx="0">
+            <a:schemeClr val="accent1"/>
+          </a:effectRef>
+          <a:fontRef idx="minor">
+            <a:schemeClr val="lt1"/>
+          </a:fontRef>
+        </p:style>
+        <p:txBody>
+          <a:bodyPr rtlCol="0" anchor="ctr"/>
+          <a:lstStyle/>
+          <a:p>
+            <a:pPr algn="ctr"/>
+            <a:endParaRPr lang="ru-RU"/>
+          </a:p>
+        </p:txBody>
+      </p:sp>
+      <p:sp>
+        <p:nvSpPr>
+          <p:cNvPr id="3" name="Прямоугольник 2">
+            <a:extLst>
+              <a:ext uri="{FF2B5EF4-FFF2-40B4-BE49-F238E27FC236}">
+                <a16:creationId xmlns:a16="http://schemas.microsoft.com/office/drawing/2014/main" id="{11754F18-C568-7D14-55B9-3DE8BDE23918}"/>
+              </a:ext>
+            </a:extLst>
+          </p:cNvPr>
+          <p:cNvSpPr/>
+          <p:nvPr/>
+        </p:nvSpPr>
+        <p:spPr>
+          <a:xfrm>
+            <a:off x="1540397" y="3717533"/>
+            <a:ext cx="360000" cy="540000"/>
+          </a:xfrm>
+          <a:prstGeom prst="rect">
+            <a:avLst/>
+          </a:prstGeom>
+        </p:spPr>
+        <p:style>
+          <a:lnRef idx="2">
+            <a:schemeClr val="accent1">
+              <a:shade val="15000"/>
+            </a:schemeClr>
+          </a:lnRef>
+          <a:fillRef idx="1">
+            <a:schemeClr val="accent1"/>
+          </a:fillRef>
+          <a:effectRef idx="0">
+            <a:schemeClr val="accent1"/>
+          </a:effectRef>
+          <a:fontRef idx="minor">
+            <a:schemeClr val="lt1"/>
+          </a:fontRef>
+        </p:style>
+        <p:txBody>
+          <a:bodyPr rtlCol="0" anchor="ctr">
+            <a:scene3d>
+              <a:camera prst="orthographicFront">
+                <a:rot lat="0" lon="0" rev="0"/>
+              </a:camera>
+              <a:lightRig rig="threePt" dir="t"/>
+            </a:scene3d>
+          </a:bodyPr>
+          <a:lstStyle/>
+          <a:p>
+            <a:pPr algn="ctr"/>
+            <a:endParaRPr lang="ru-RU" dirty="0"/>
+          </a:p>
+        </p:txBody>
+      </p:sp>
+      <p:sp>
+        <p:nvSpPr>
+          <p:cNvPr id="4" name="Прямоугольник 3">
+            <a:extLst>
+              <a:ext uri="{FF2B5EF4-FFF2-40B4-BE49-F238E27FC236}">
+                <a16:creationId xmlns:a16="http://schemas.microsoft.com/office/drawing/2014/main" id="{4E9FD20D-E304-6395-B596-31102EA3BF74}"/>
+              </a:ext>
+            </a:extLst>
+          </p:cNvPr>
+          <p:cNvSpPr/>
+          <p:nvPr/>
+        </p:nvSpPr>
+        <p:spPr>
+          <a:xfrm>
+            <a:off x="1900397" y="3717533"/>
+            <a:ext cx="360000" cy="540000"/>
+          </a:xfrm>
+          <a:prstGeom prst="rect">
+            <a:avLst/>
+          </a:prstGeom>
+        </p:spPr>
+        <p:style>
+          <a:lnRef idx="2">
+            <a:schemeClr val="accent1">
+              <a:shade val="15000"/>
+            </a:schemeClr>
+          </a:lnRef>
+          <a:fillRef idx="1">
+            <a:schemeClr val="accent1"/>
+          </a:fillRef>
+          <a:effectRef idx="0">
+            <a:schemeClr val="accent1"/>
+          </a:effectRef>
+          <a:fontRef idx="minor">
+            <a:schemeClr val="lt1"/>
+          </a:fontRef>
+        </p:style>
+        <p:txBody>
+          <a:bodyPr rtlCol="0" anchor="ctr"/>
+          <a:lstStyle/>
+          <a:p>
+            <a:pPr algn="ctr"/>
+            <a:endParaRPr lang="ru-RU"/>
+          </a:p>
+        </p:txBody>
+      </p:sp>
+      <p:sp>
+        <p:nvSpPr>
+          <p:cNvPr id="13" name="Прямоугольник 12">
+            <a:extLst>
+              <a:ext uri="{FF2B5EF4-FFF2-40B4-BE49-F238E27FC236}">
+                <a16:creationId xmlns:a16="http://schemas.microsoft.com/office/drawing/2014/main" id="{D010ED5E-C301-50E8-3844-D45FEEFFD3DE}"/>
+              </a:ext>
+            </a:extLst>
+          </p:cNvPr>
+          <p:cNvSpPr/>
+          <p:nvPr/>
+        </p:nvSpPr>
+        <p:spPr>
+          <a:xfrm>
+            <a:off x="2260397" y="3717533"/>
+            <a:ext cx="360000" cy="540000"/>
+          </a:xfrm>
+          <a:prstGeom prst="rect">
+            <a:avLst/>
+          </a:prstGeom>
+        </p:spPr>
+        <p:style>
+          <a:lnRef idx="2">
+            <a:schemeClr val="accent1">
+              <a:shade val="15000"/>
+            </a:schemeClr>
+          </a:lnRef>
+          <a:fillRef idx="1">
+            <a:schemeClr val="accent1"/>
+          </a:fillRef>
+          <a:effectRef idx="0">
+            <a:schemeClr val="accent1"/>
+          </a:effectRef>
+          <a:fontRef idx="minor">
+            <a:schemeClr val="lt1"/>
+          </a:fontRef>
+        </p:style>
+        <p:txBody>
+          <a:bodyPr rtlCol="0" anchor="ctr"/>
+          <a:lstStyle/>
+          <a:p>
+            <a:pPr algn="ctr"/>
+            <a:endParaRPr lang="ru-RU"/>
+          </a:p>
+        </p:txBody>
+      </p:sp>
+      <p:sp>
+        <p:nvSpPr>
+          <p:cNvPr id="14" name="Прямоугольник 13">
+            <a:extLst>
+              <a:ext uri="{FF2B5EF4-FFF2-40B4-BE49-F238E27FC236}">
+                <a16:creationId xmlns:a16="http://schemas.microsoft.com/office/drawing/2014/main" id="{22E6BB34-7333-3128-5763-8BC0D8C778BC}"/>
+              </a:ext>
+            </a:extLst>
+          </p:cNvPr>
+          <p:cNvSpPr/>
+          <p:nvPr/>
+        </p:nvSpPr>
+        <p:spPr>
+          <a:xfrm>
+            <a:off x="2677993" y="3716268"/>
+            <a:ext cx="1080000" cy="540000"/>
+          </a:xfrm>
+          <a:prstGeom prst="rect">
+            <a:avLst/>
+          </a:prstGeom>
+          <a:noFill/>
+          <a:ln>
+            <a:solidFill>
+              <a:schemeClr val="tx1"/>
+            </a:solidFill>
+          </a:ln>
+        </p:spPr>
+        <p:style>
+          <a:lnRef idx="2">
+            <a:schemeClr val="accent1">
+              <a:shade val="15000"/>
+            </a:schemeClr>
+          </a:lnRef>
+          <a:fillRef idx="1">
+            <a:schemeClr val="accent1"/>
+          </a:fillRef>
+          <a:effectRef idx="0">
+            <a:schemeClr val="accent1"/>
+          </a:effectRef>
+          <a:fontRef idx="minor">
+            <a:schemeClr val="lt1"/>
+          </a:fontRef>
+        </p:style>
+        <p:txBody>
+          <a:bodyPr rtlCol="0" anchor="ctr"/>
+          <a:lstStyle/>
+          <a:p>
+            <a:pPr algn="ctr"/>
+            <a:endParaRPr lang="ru-RU"/>
+          </a:p>
+        </p:txBody>
+      </p:sp>
+      <p:sp>
+        <p:nvSpPr>
+          <p:cNvPr id="15" name="Прямоугольник 14">
+            <a:extLst>
+              <a:ext uri="{FF2B5EF4-FFF2-40B4-BE49-F238E27FC236}">
+                <a16:creationId xmlns:a16="http://schemas.microsoft.com/office/drawing/2014/main" id="{E755B7C4-05C8-625F-876D-2BB43E3F9E26}"/>
+              </a:ext>
+            </a:extLst>
+          </p:cNvPr>
+          <p:cNvSpPr/>
+          <p:nvPr/>
+        </p:nvSpPr>
+        <p:spPr>
+          <a:xfrm>
+            <a:off x="2677993" y="3716268"/>
+            <a:ext cx="360000" cy="540000"/>
+          </a:xfrm>
+          <a:prstGeom prst="rect">
+            <a:avLst/>
+          </a:prstGeom>
+        </p:spPr>
+        <p:style>
+          <a:lnRef idx="2">
+            <a:schemeClr val="accent1">
+              <a:shade val="15000"/>
+            </a:schemeClr>
+          </a:lnRef>
+          <a:fillRef idx="1">
+            <a:schemeClr val="accent1"/>
+          </a:fillRef>
+          <a:effectRef idx="0">
+            <a:schemeClr val="accent1"/>
+          </a:effectRef>
+          <a:fontRef idx="minor">
+            <a:schemeClr val="lt1"/>
+          </a:fontRef>
+        </p:style>
+        <p:txBody>
+          <a:bodyPr rtlCol="0" anchor="ctr"/>
+          <a:lstStyle/>
+          <a:p>
+            <a:pPr algn="ctr"/>
+            <a:endParaRPr lang="ru-RU" dirty="0"/>
+          </a:p>
+        </p:txBody>
+      </p:sp>
+      <p:sp>
+        <p:nvSpPr>
+          <p:cNvPr id="16" name="Прямоугольник 15">
+            <a:extLst>
+              <a:ext uri="{FF2B5EF4-FFF2-40B4-BE49-F238E27FC236}">
+                <a16:creationId xmlns:a16="http://schemas.microsoft.com/office/drawing/2014/main" id="{E56E2F25-9BB5-8EDE-B16F-835B84CC38CB}"/>
+              </a:ext>
+            </a:extLst>
+          </p:cNvPr>
+          <p:cNvSpPr/>
+          <p:nvPr/>
+        </p:nvSpPr>
+        <p:spPr>
+          <a:xfrm>
+            <a:off x="3037993" y="3716268"/>
+            <a:ext cx="360000" cy="540000"/>
+          </a:xfrm>
+          <a:prstGeom prst="rect">
+            <a:avLst/>
+          </a:prstGeom>
+        </p:spPr>
+        <p:style>
+          <a:lnRef idx="2">
+            <a:schemeClr val="accent1">
+              <a:shade val="15000"/>
+            </a:schemeClr>
+          </a:lnRef>
+          <a:fillRef idx="1">
+            <a:schemeClr val="accent1"/>
+          </a:fillRef>
+          <a:effectRef idx="0">
+            <a:schemeClr val="accent1"/>
+          </a:effectRef>
+          <a:fontRef idx="minor">
+            <a:schemeClr val="lt1"/>
+          </a:fontRef>
+        </p:style>
+        <p:txBody>
+          <a:bodyPr rtlCol="0" anchor="ctr"/>
+          <a:lstStyle/>
+          <a:p>
+            <a:pPr algn="ctr"/>
+            <a:endParaRPr lang="ru-RU"/>
+          </a:p>
+        </p:txBody>
+      </p:sp>
+      <p:sp>
+        <p:nvSpPr>
+          <p:cNvPr id="17" name="Прямоугольник 16">
+            <a:extLst>
+              <a:ext uri="{FF2B5EF4-FFF2-40B4-BE49-F238E27FC236}">
+                <a16:creationId xmlns:a16="http://schemas.microsoft.com/office/drawing/2014/main" id="{EFB83BD5-623A-3F78-841C-054ACBF708FF}"/>
+              </a:ext>
+            </a:extLst>
+          </p:cNvPr>
+          <p:cNvSpPr/>
+          <p:nvPr/>
+        </p:nvSpPr>
+        <p:spPr>
+          <a:xfrm>
+            <a:off x="3397993" y="3716268"/>
+            <a:ext cx="360000" cy="540000"/>
+          </a:xfrm>
+          <a:prstGeom prst="rect">
+            <a:avLst/>
+          </a:prstGeom>
+        </p:spPr>
+        <p:style>
+          <a:lnRef idx="2">
+            <a:schemeClr val="accent1">
+              <a:shade val="15000"/>
+            </a:schemeClr>
+          </a:lnRef>
+          <a:fillRef idx="1">
+            <a:schemeClr val="accent1"/>
+          </a:fillRef>
+          <a:effectRef idx="0">
+            <a:schemeClr val="accent1"/>
+          </a:effectRef>
+          <a:fontRef idx="minor">
+            <a:schemeClr val="lt1"/>
+          </a:fontRef>
+        </p:style>
+        <p:txBody>
+          <a:bodyPr rtlCol="0" anchor="ctr"/>
+          <a:lstStyle/>
+          <a:p>
+            <a:pPr algn="ctr"/>
+            <a:endParaRPr lang="ru-RU"/>
+          </a:p>
+        </p:txBody>
+      </p:sp>
+      <p:sp>
+        <p:nvSpPr>
+          <p:cNvPr id="36" name="Прямоугольник 35">
+            <a:extLst>
+              <a:ext uri="{FF2B5EF4-FFF2-40B4-BE49-F238E27FC236}">
+                <a16:creationId xmlns:a16="http://schemas.microsoft.com/office/drawing/2014/main" id="{F5F076E7-28CA-5926-9B5E-1B41D274D629}"/>
+              </a:ext>
+            </a:extLst>
+          </p:cNvPr>
+          <p:cNvSpPr/>
+          <p:nvPr/>
+        </p:nvSpPr>
+        <p:spPr>
+          <a:xfrm>
+            <a:off x="3810111" y="3715636"/>
+            <a:ext cx="1080000" cy="540000"/>
+          </a:xfrm>
+          <a:prstGeom prst="rect">
+            <a:avLst/>
+          </a:prstGeom>
+          <a:noFill/>
+          <a:ln>
+            <a:solidFill>
+              <a:schemeClr val="tx1"/>
+            </a:solidFill>
+          </a:ln>
+        </p:spPr>
+        <p:style>
+          <a:lnRef idx="2">
+            <a:schemeClr val="accent1">
+              <a:shade val="15000"/>
+            </a:schemeClr>
+          </a:lnRef>
+          <a:fillRef idx="1">
+            <a:schemeClr val="accent1"/>
+          </a:fillRef>
+          <a:effectRef idx="0">
+            <a:schemeClr val="accent1"/>
+          </a:effectRef>
+          <a:fontRef idx="minor">
+            <a:schemeClr val="lt1"/>
+          </a:fontRef>
+        </p:style>
+        <p:txBody>
+          <a:bodyPr rtlCol="0" anchor="ctr"/>
+          <a:lstStyle/>
+          <a:p>
+            <a:pPr algn="ctr"/>
+            <a:endParaRPr lang="ru-RU"/>
+          </a:p>
+        </p:txBody>
+      </p:sp>
+      <p:sp>
+        <p:nvSpPr>
+          <p:cNvPr id="37" name="Прямоугольник 36">
+            <a:extLst>
+              <a:ext uri="{FF2B5EF4-FFF2-40B4-BE49-F238E27FC236}">
+                <a16:creationId xmlns:a16="http://schemas.microsoft.com/office/drawing/2014/main" id="{AAD30FD4-60D0-F331-4306-C4E92E76F8F1}"/>
+              </a:ext>
+            </a:extLst>
+          </p:cNvPr>
+          <p:cNvSpPr/>
+          <p:nvPr/>
+        </p:nvSpPr>
+        <p:spPr>
+          <a:xfrm>
+            <a:off x="3810111" y="3715636"/>
+            <a:ext cx="360000" cy="540000"/>
+          </a:xfrm>
+          <a:prstGeom prst="rect">
+            <a:avLst/>
+          </a:prstGeom>
+        </p:spPr>
+        <p:style>
+          <a:lnRef idx="2">
+            <a:schemeClr val="accent1">
+              <a:shade val="15000"/>
+            </a:schemeClr>
+          </a:lnRef>
+          <a:fillRef idx="1">
+            <a:schemeClr val="accent1"/>
+          </a:fillRef>
+          <a:effectRef idx="0">
+            <a:schemeClr val="accent1"/>
+          </a:effectRef>
+          <a:fontRef idx="minor">
+            <a:schemeClr val="lt1"/>
+          </a:fontRef>
+        </p:style>
+        <p:txBody>
+          <a:bodyPr rtlCol="0" anchor="ctr"/>
+          <a:lstStyle/>
+          <a:p>
+            <a:pPr algn="ctr"/>
+            <a:endParaRPr lang="ru-RU"/>
+          </a:p>
+        </p:txBody>
+      </p:sp>
+      <p:sp>
+        <p:nvSpPr>
+          <p:cNvPr id="40" name="Прямоугольник 39">
+            <a:extLst>
+              <a:ext uri="{FF2B5EF4-FFF2-40B4-BE49-F238E27FC236}">
+                <a16:creationId xmlns:a16="http://schemas.microsoft.com/office/drawing/2014/main" id="{637D961D-8F36-CED6-592B-EEFE472426A5}"/>
+              </a:ext>
+            </a:extLst>
+          </p:cNvPr>
+          <p:cNvSpPr/>
+          <p:nvPr/>
+        </p:nvSpPr>
+        <p:spPr>
+          <a:xfrm>
+            <a:off x="4170111" y="3715636"/>
+            <a:ext cx="360000" cy="540000"/>
+          </a:xfrm>
+          <a:prstGeom prst="rect">
+            <a:avLst/>
+          </a:prstGeom>
+        </p:spPr>
+        <p:style>
+          <a:lnRef idx="2">
+            <a:schemeClr val="accent1">
+              <a:shade val="15000"/>
+            </a:schemeClr>
+          </a:lnRef>
+          <a:fillRef idx="1">
+            <a:schemeClr val="accent1"/>
+          </a:fillRef>
+          <a:effectRef idx="0">
+            <a:schemeClr val="accent1"/>
+          </a:effectRef>
+          <a:fontRef idx="minor">
+            <a:schemeClr val="lt1"/>
+          </a:fontRef>
+        </p:style>
+        <p:txBody>
+          <a:bodyPr rtlCol="0" anchor="ctr"/>
+          <a:lstStyle/>
+          <a:p>
+            <a:pPr algn="ctr"/>
+            <a:endParaRPr lang="ru-RU"/>
+          </a:p>
+        </p:txBody>
+      </p:sp>
+      <p:sp>
+        <p:nvSpPr>
+          <p:cNvPr id="43" name="Прямоугольник 42">
+            <a:extLst>
+              <a:ext uri="{FF2B5EF4-FFF2-40B4-BE49-F238E27FC236}">
+                <a16:creationId xmlns:a16="http://schemas.microsoft.com/office/drawing/2014/main" id="{6BD03E50-3415-6F71-7114-FB87130E83CC}"/>
+              </a:ext>
+            </a:extLst>
+          </p:cNvPr>
+          <p:cNvSpPr/>
+          <p:nvPr/>
+        </p:nvSpPr>
+        <p:spPr>
+          <a:xfrm>
+            <a:off x="4530111" y="3715636"/>
+            <a:ext cx="360000" cy="540000"/>
+          </a:xfrm>
+          <a:prstGeom prst="rect">
+            <a:avLst/>
+          </a:prstGeom>
+        </p:spPr>
+        <p:style>
+          <a:lnRef idx="2">
+            <a:schemeClr val="accent1">
+              <a:shade val="15000"/>
+            </a:schemeClr>
+          </a:lnRef>
+          <a:fillRef idx="1">
+            <a:schemeClr val="accent1"/>
+          </a:fillRef>
+          <a:effectRef idx="0">
+            <a:schemeClr val="accent1"/>
+          </a:effectRef>
+          <a:fontRef idx="minor">
+            <a:schemeClr val="lt1"/>
+          </a:fontRef>
+        </p:style>
+        <p:txBody>
+          <a:bodyPr rtlCol="0" anchor="ctr"/>
+          <a:lstStyle/>
+          <a:p>
+            <a:pPr algn="ctr"/>
+            <a:endParaRPr lang="ru-RU"/>
+          </a:p>
+        </p:txBody>
+      </p:sp>
+      <p:sp>
+        <p:nvSpPr>
+          <p:cNvPr id="45" name="Прямоугольник 44">
+            <a:extLst>
+              <a:ext uri="{FF2B5EF4-FFF2-40B4-BE49-F238E27FC236}">
+                <a16:creationId xmlns:a16="http://schemas.microsoft.com/office/drawing/2014/main" id="{E24D8AAD-C779-8E59-CBE8-99ABE4A78631}"/>
+              </a:ext>
+            </a:extLst>
+          </p:cNvPr>
+          <p:cNvSpPr/>
+          <p:nvPr/>
+        </p:nvSpPr>
+        <p:spPr>
+          <a:xfrm>
+            <a:off x="4945206" y="3715636"/>
+            <a:ext cx="1080000" cy="540000"/>
+          </a:xfrm>
+          <a:prstGeom prst="rect">
+            <a:avLst/>
+          </a:prstGeom>
+          <a:noFill/>
+          <a:ln>
+            <a:solidFill>
+              <a:schemeClr val="tx1"/>
+            </a:solidFill>
+          </a:ln>
+        </p:spPr>
+        <p:style>
+          <a:lnRef idx="2">
+            <a:schemeClr val="accent1">
+              <a:shade val="15000"/>
+            </a:schemeClr>
+          </a:lnRef>
+          <a:fillRef idx="1">
+            <a:schemeClr val="accent1"/>
+          </a:fillRef>
+          <a:effectRef idx="0">
+            <a:schemeClr val="accent1"/>
+          </a:effectRef>
+          <a:fontRef idx="minor">
+            <a:schemeClr val="lt1"/>
+          </a:fontRef>
+        </p:style>
+        <p:txBody>
+          <a:bodyPr rtlCol="0" anchor="ctr"/>
+          <a:lstStyle/>
+          <a:p>
+            <a:pPr algn="ctr"/>
+            <a:endParaRPr lang="ru-RU"/>
+          </a:p>
+        </p:txBody>
+      </p:sp>
+      <p:sp>
+        <p:nvSpPr>
+          <p:cNvPr id="46" name="Прямоугольник 45">
+            <a:extLst>
+              <a:ext uri="{FF2B5EF4-FFF2-40B4-BE49-F238E27FC236}">
+                <a16:creationId xmlns:a16="http://schemas.microsoft.com/office/drawing/2014/main" id="{2BADEFFB-6AD8-EAA8-2723-59417A4D468E}"/>
+              </a:ext>
+            </a:extLst>
+          </p:cNvPr>
+          <p:cNvSpPr/>
+          <p:nvPr/>
+        </p:nvSpPr>
+        <p:spPr>
+          <a:xfrm>
+            <a:off x="4945206" y="3715636"/>
+            <a:ext cx="360000" cy="540000"/>
+          </a:xfrm>
+          <a:prstGeom prst="rect">
+            <a:avLst/>
+          </a:prstGeom>
+        </p:spPr>
+        <p:style>
+          <a:lnRef idx="2">
+            <a:schemeClr val="accent1">
+              <a:shade val="15000"/>
+            </a:schemeClr>
+          </a:lnRef>
+          <a:fillRef idx="1">
+            <a:schemeClr val="accent1"/>
+          </a:fillRef>
+          <a:effectRef idx="0">
+            <a:schemeClr val="accent1"/>
+          </a:effectRef>
+          <a:fontRef idx="minor">
+            <a:schemeClr val="lt1"/>
+          </a:fontRef>
+        </p:style>
+        <p:txBody>
+          <a:bodyPr rtlCol="0" anchor="ctr"/>
+          <a:lstStyle/>
+          <a:p>
+            <a:pPr algn="ctr"/>
+            <a:endParaRPr lang="ru-RU"/>
+          </a:p>
+        </p:txBody>
+      </p:sp>
+      <p:sp>
+        <p:nvSpPr>
+          <p:cNvPr id="47" name="Прямоугольник 46">
+            <a:extLst>
+              <a:ext uri="{FF2B5EF4-FFF2-40B4-BE49-F238E27FC236}">
+                <a16:creationId xmlns:a16="http://schemas.microsoft.com/office/drawing/2014/main" id="{B6450164-82C0-94E2-5970-1E38746D6BD6}"/>
+              </a:ext>
+            </a:extLst>
+          </p:cNvPr>
+          <p:cNvSpPr/>
+          <p:nvPr/>
+        </p:nvSpPr>
+        <p:spPr>
+          <a:xfrm>
+            <a:off x="5305206" y="3715636"/>
+            <a:ext cx="360000" cy="540000"/>
+          </a:xfrm>
+          <a:prstGeom prst="rect">
+            <a:avLst/>
+          </a:prstGeom>
+        </p:spPr>
+        <p:style>
+          <a:lnRef idx="2">
+            <a:schemeClr val="accent1">
+              <a:shade val="15000"/>
+            </a:schemeClr>
+          </a:lnRef>
+          <a:fillRef idx="1">
+            <a:schemeClr val="accent1"/>
+          </a:fillRef>
+          <a:effectRef idx="0">
+            <a:schemeClr val="accent1"/>
+          </a:effectRef>
+          <a:fontRef idx="minor">
+            <a:schemeClr val="lt1"/>
+          </a:fontRef>
+        </p:style>
+        <p:txBody>
+          <a:bodyPr rtlCol="0" anchor="ctr"/>
+          <a:lstStyle/>
+          <a:p>
+            <a:pPr algn="ctr"/>
+            <a:endParaRPr lang="ru-RU"/>
+          </a:p>
+        </p:txBody>
+      </p:sp>
+      <p:sp>
+        <p:nvSpPr>
+          <p:cNvPr id="48" name="Прямоугольник 47">
+            <a:extLst>
+              <a:ext uri="{FF2B5EF4-FFF2-40B4-BE49-F238E27FC236}">
+                <a16:creationId xmlns:a16="http://schemas.microsoft.com/office/drawing/2014/main" id="{4CC60648-39BA-942C-C7EE-C361CAD70F28}"/>
+              </a:ext>
+            </a:extLst>
+          </p:cNvPr>
+          <p:cNvSpPr/>
+          <p:nvPr/>
+        </p:nvSpPr>
+        <p:spPr>
+          <a:xfrm>
+            <a:off x="5665206" y="3715636"/>
+            <a:ext cx="360000" cy="540000"/>
+          </a:xfrm>
+          <a:prstGeom prst="rect">
+            <a:avLst/>
+          </a:prstGeom>
+        </p:spPr>
+        <p:style>
+          <a:lnRef idx="2">
+            <a:schemeClr val="accent1">
+              <a:shade val="15000"/>
+            </a:schemeClr>
+          </a:lnRef>
+          <a:fillRef idx="1">
+            <a:schemeClr val="accent1"/>
+          </a:fillRef>
+          <a:effectRef idx="0">
+            <a:schemeClr val="accent1"/>
+          </a:effectRef>
+          <a:fontRef idx="minor">
+            <a:schemeClr val="lt1"/>
+          </a:fontRef>
+        </p:style>
+        <p:txBody>
+          <a:bodyPr rtlCol="0" anchor="ctr"/>
+          <a:lstStyle/>
+          <a:p>
+            <a:pPr algn="ctr"/>
+            <a:endParaRPr lang="ru-RU"/>
+          </a:p>
+        </p:txBody>
+      </p:sp>
+      <p:cxnSp>
+        <p:nvCxnSpPr>
+          <p:cNvPr id="50" name="Прямая соединительная линия 49">
+            <a:extLst>
+              <a:ext uri="{FF2B5EF4-FFF2-40B4-BE49-F238E27FC236}">
+                <a16:creationId xmlns:a16="http://schemas.microsoft.com/office/drawing/2014/main" id="{C91B2A51-5BE7-A5F6-CE2D-5BC0A24DF86A}"/>
+              </a:ext>
+            </a:extLst>
+          </p:cNvPr>
+          <p:cNvCxnSpPr>
+            <a:cxnSpLocks/>
+          </p:cNvCxnSpPr>
+          <p:nvPr/>
+        </p:nvCxnSpPr>
+        <p:spPr>
+          <a:xfrm>
+            <a:off x="2261435" y="4255636"/>
+            <a:ext cx="0" cy="330966"/>
+          </a:xfrm>
+          <a:prstGeom prst="line">
+            <a:avLst/>
+          </a:prstGeom>
+        </p:spPr>
+        <p:style>
+          <a:lnRef idx="1">
+            <a:schemeClr val="accent1"/>
+          </a:lnRef>
+          <a:fillRef idx="0">
+            <a:schemeClr val="accent1"/>
+          </a:fillRef>
+          <a:effectRef idx="0">
+            <a:schemeClr val="accent1"/>
+          </a:effectRef>
+          <a:fontRef idx="minor">
+            <a:schemeClr val="tx1"/>
+          </a:fontRef>
+        </p:style>
+      </p:cxnSp>
+      <p:cxnSp>
+        <p:nvCxnSpPr>
+          <p:cNvPr id="57" name="Прямая соединительная линия 56">
+            <a:extLst>
+              <a:ext uri="{FF2B5EF4-FFF2-40B4-BE49-F238E27FC236}">
+                <a16:creationId xmlns:a16="http://schemas.microsoft.com/office/drawing/2014/main" id="{55835280-48E7-6EB7-4001-7B4BACE858DC}"/>
+              </a:ext>
+            </a:extLst>
+          </p:cNvPr>
+          <p:cNvCxnSpPr>
+            <a:cxnSpLocks/>
+          </p:cNvCxnSpPr>
+          <p:nvPr/>
+        </p:nvCxnSpPr>
+        <p:spPr>
+          <a:xfrm flipH="1">
+            <a:off x="5302586" y="4255636"/>
+            <a:ext cx="3138" cy="330966"/>
+          </a:xfrm>
+          <a:prstGeom prst="line">
+            <a:avLst/>
+          </a:prstGeom>
+        </p:spPr>
+        <p:style>
+          <a:lnRef idx="1">
+            <a:schemeClr val="accent1"/>
+          </a:lnRef>
+          <a:fillRef idx="0">
+            <a:schemeClr val="accent1"/>
+          </a:fillRef>
+          <a:effectRef idx="0">
+            <a:schemeClr val="accent1"/>
+          </a:effectRef>
+          <a:fontRef idx="minor">
+            <a:schemeClr val="tx1"/>
+          </a:fontRef>
+        </p:style>
+      </p:cxnSp>
+      <p:cxnSp>
+        <p:nvCxnSpPr>
+          <p:cNvPr id="58" name="Прямая со стрелкой 57">
+            <a:extLst>
+              <a:ext uri="{FF2B5EF4-FFF2-40B4-BE49-F238E27FC236}">
+                <a16:creationId xmlns:a16="http://schemas.microsoft.com/office/drawing/2014/main" id="{D0BF92AF-E960-83F7-C965-EAE3125D6EEB}"/>
+              </a:ext>
+            </a:extLst>
+          </p:cNvPr>
+          <p:cNvCxnSpPr>
+            <a:cxnSpLocks/>
+          </p:cNvCxnSpPr>
+          <p:nvPr/>
+        </p:nvCxnSpPr>
+        <p:spPr>
+          <a:xfrm>
+            <a:off x="2261435" y="4588499"/>
+            <a:ext cx="3041151" cy="0"/>
+          </a:xfrm>
+          <a:prstGeom prst="straightConnector1">
+            <a:avLst/>
+          </a:prstGeom>
+          <a:ln>
+            <a:headEnd type="triangle"/>
+            <a:tailEnd type="triangle"/>
+          </a:ln>
+        </p:spPr>
+        <p:style>
+          <a:lnRef idx="1">
+            <a:schemeClr val="accent1"/>
+          </a:lnRef>
+          <a:fillRef idx="0">
+            <a:schemeClr val="accent1"/>
+          </a:fillRef>
+          <a:effectRef idx="0">
+            <a:schemeClr val="accent1"/>
+          </a:effectRef>
+          <a:fontRef idx="minor">
+            <a:schemeClr val="tx1"/>
+          </a:fontRef>
+        </p:style>
+      </p:cxnSp>
+      <p:sp>
+        <p:nvSpPr>
+          <p:cNvPr id="59" name="TextBox 58">
+            <a:extLst>
+              <a:ext uri="{FF2B5EF4-FFF2-40B4-BE49-F238E27FC236}">
+                <a16:creationId xmlns:a16="http://schemas.microsoft.com/office/drawing/2014/main" id="{82A9D922-719F-A079-0A36-640DB01CA402}"/>
+              </a:ext>
+            </a:extLst>
+          </p:cNvPr>
+          <p:cNvSpPr txBox="1"/>
+          <p:nvPr/>
+        </p:nvSpPr>
+        <p:spPr>
+          <a:xfrm>
+            <a:off x="3349888" y="4605326"/>
+            <a:ext cx="1096775" cy="307777"/>
+          </a:xfrm>
+          <a:prstGeom prst="rect">
+            <a:avLst/>
+          </a:prstGeom>
+          <a:noFill/>
+        </p:spPr>
+        <p:txBody>
+          <a:bodyPr wrap="none" rtlCol="0">
+            <a:spAutoFit/>
+          </a:bodyPr>
+          <a:lstStyle/>
+          <a:p>
+            <a:r>
+              <a:rPr lang="en-US" sz="1400" dirty="0"/>
+              <a:t>180° 32mag </a:t>
+            </a:r>
+            <a:endParaRPr lang="ru-RU" sz="1400" dirty="0"/>
+          </a:p>
+        </p:txBody>
+      </p:sp>
+      <p:cxnSp>
+        <p:nvCxnSpPr>
+          <p:cNvPr id="60" name="Прямая соединительная линия 59">
+            <a:extLst>
+              <a:ext uri="{FF2B5EF4-FFF2-40B4-BE49-F238E27FC236}">
+                <a16:creationId xmlns:a16="http://schemas.microsoft.com/office/drawing/2014/main" id="{D3F742FC-73FC-5850-675F-43215F66C9C7}"/>
+              </a:ext>
+            </a:extLst>
+          </p:cNvPr>
+          <p:cNvCxnSpPr>
+            <a:cxnSpLocks/>
+          </p:cNvCxnSpPr>
+          <p:nvPr/>
+        </p:nvCxnSpPr>
+        <p:spPr>
+          <a:xfrm>
+            <a:off x="1540397" y="4257533"/>
+            <a:ext cx="0" cy="330966"/>
+          </a:xfrm>
+          <a:prstGeom prst="line">
+            <a:avLst/>
+          </a:prstGeom>
+        </p:spPr>
+        <p:style>
+          <a:lnRef idx="1">
+            <a:schemeClr val="accent1"/>
+          </a:lnRef>
+          <a:fillRef idx="0">
+            <a:schemeClr val="accent1"/>
+          </a:fillRef>
+          <a:effectRef idx="0">
+            <a:schemeClr val="accent1"/>
+          </a:effectRef>
+          <a:fontRef idx="minor">
+            <a:schemeClr val="tx1"/>
+          </a:fontRef>
+        </p:style>
+      </p:cxnSp>
+      <p:cxnSp>
+        <p:nvCxnSpPr>
+          <p:cNvPr id="61" name="Прямая со стрелкой 60">
+            <a:extLst>
+              <a:ext uri="{FF2B5EF4-FFF2-40B4-BE49-F238E27FC236}">
+                <a16:creationId xmlns:a16="http://schemas.microsoft.com/office/drawing/2014/main" id="{4268C928-6461-EF59-3DE6-69383669BA2A}"/>
+              </a:ext>
+            </a:extLst>
+          </p:cNvPr>
+          <p:cNvCxnSpPr>
+            <a:cxnSpLocks/>
+          </p:cNvCxnSpPr>
+          <p:nvPr/>
+        </p:nvCxnSpPr>
+        <p:spPr>
+          <a:xfrm>
+            <a:off x="1540397" y="4587234"/>
+            <a:ext cx="730897" cy="0"/>
+          </a:xfrm>
+          <a:prstGeom prst="straightConnector1">
+            <a:avLst/>
+          </a:prstGeom>
+          <a:ln>
+            <a:headEnd type="triangle"/>
+            <a:tailEnd type="triangle"/>
+          </a:ln>
+        </p:spPr>
+        <p:style>
+          <a:lnRef idx="1">
+            <a:schemeClr val="accent1"/>
+          </a:lnRef>
+          <a:fillRef idx="0">
+            <a:schemeClr val="accent1"/>
+          </a:fillRef>
+          <a:effectRef idx="0">
+            <a:schemeClr val="accent1"/>
+          </a:effectRef>
+          <a:fontRef idx="minor">
+            <a:schemeClr val="tx1"/>
+          </a:fontRef>
+        </p:style>
+      </p:cxnSp>
+      <p:cxnSp>
+        <p:nvCxnSpPr>
+          <p:cNvPr id="63" name="Прямая со стрелкой 62">
+            <a:extLst>
+              <a:ext uri="{FF2B5EF4-FFF2-40B4-BE49-F238E27FC236}">
+                <a16:creationId xmlns:a16="http://schemas.microsoft.com/office/drawing/2014/main" id="{27135B57-980B-7295-75CE-CDBA6A15E3F0}"/>
+              </a:ext>
+            </a:extLst>
+          </p:cNvPr>
+          <p:cNvCxnSpPr>
+            <a:cxnSpLocks/>
+          </p:cNvCxnSpPr>
+          <p:nvPr/>
+        </p:nvCxnSpPr>
+        <p:spPr>
+          <a:xfrm>
+            <a:off x="5302586" y="4586602"/>
+            <a:ext cx="722620" cy="0"/>
+          </a:xfrm>
+          <a:prstGeom prst="straightConnector1">
+            <a:avLst/>
+          </a:prstGeom>
+          <a:ln>
+            <a:headEnd type="triangle"/>
+            <a:tailEnd type="triangle"/>
+          </a:ln>
+        </p:spPr>
+        <p:style>
+          <a:lnRef idx="1">
+            <a:schemeClr val="accent1"/>
+          </a:lnRef>
+          <a:fillRef idx="0">
+            <a:schemeClr val="accent1"/>
+          </a:fillRef>
+          <a:effectRef idx="0">
+            <a:schemeClr val="accent1"/>
+          </a:effectRef>
+          <a:fontRef idx="minor">
+            <a:schemeClr val="tx1"/>
+          </a:fontRef>
+        </p:style>
+      </p:cxnSp>
+      <p:sp>
+        <p:nvSpPr>
+          <p:cNvPr id="67" name="TextBox 66">
+            <a:extLst>
+              <a:ext uri="{FF2B5EF4-FFF2-40B4-BE49-F238E27FC236}">
+                <a16:creationId xmlns:a16="http://schemas.microsoft.com/office/drawing/2014/main" id="{3A1C3E6D-3249-8FBC-831D-E570D85E76ED}"/>
+              </a:ext>
+            </a:extLst>
+          </p:cNvPr>
+          <p:cNvSpPr txBox="1"/>
+          <p:nvPr/>
+        </p:nvSpPr>
+        <p:spPr>
+          <a:xfrm>
+            <a:off x="5300492" y="4592293"/>
+            <a:ext cx="920441" cy="307777"/>
+          </a:xfrm>
+          <a:prstGeom prst="rect">
+            <a:avLst/>
+          </a:prstGeom>
+          <a:noFill/>
+        </p:spPr>
+        <p:txBody>
+          <a:bodyPr wrap="square" rtlCol="0">
+            <a:spAutoFit/>
+          </a:bodyPr>
+          <a:lstStyle/>
+          <a:p>
+            <a:r>
+              <a:rPr lang="en-US" sz="1400" dirty="0"/>
+              <a:t>45° 8 mag</a:t>
+            </a:r>
+          </a:p>
+        </p:txBody>
+      </p:sp>
+      <p:cxnSp>
+        <p:nvCxnSpPr>
+          <p:cNvPr id="75" name="Прямая соединительная линия 74">
+            <a:extLst>
+              <a:ext uri="{FF2B5EF4-FFF2-40B4-BE49-F238E27FC236}">
+                <a16:creationId xmlns:a16="http://schemas.microsoft.com/office/drawing/2014/main" id="{1D2E0850-EEA2-CF0A-EB83-EFD697D47324}"/>
+              </a:ext>
+            </a:extLst>
+          </p:cNvPr>
+          <p:cNvCxnSpPr>
+            <a:cxnSpLocks/>
+          </p:cNvCxnSpPr>
+          <p:nvPr/>
+        </p:nvCxnSpPr>
+        <p:spPr>
+          <a:xfrm>
+            <a:off x="6025206" y="4255636"/>
+            <a:ext cx="0" cy="330966"/>
+          </a:xfrm>
+          <a:prstGeom prst="line">
+            <a:avLst/>
+          </a:prstGeom>
+        </p:spPr>
+        <p:style>
+          <a:lnRef idx="1">
+            <a:schemeClr val="accent1"/>
+          </a:lnRef>
+          <a:fillRef idx="0">
+            <a:schemeClr val="accent1"/>
+          </a:fillRef>
+          <a:effectRef idx="0">
+            <a:schemeClr val="accent1"/>
+          </a:effectRef>
+          <a:fontRef idx="minor">
+            <a:schemeClr val="tx1"/>
+          </a:fontRef>
+        </p:style>
+      </p:cxnSp>
+      <p:sp>
+        <p:nvSpPr>
+          <p:cNvPr id="83" name="TextBox 82">
+            <a:extLst>
+              <a:ext uri="{FF2B5EF4-FFF2-40B4-BE49-F238E27FC236}">
+                <a16:creationId xmlns:a16="http://schemas.microsoft.com/office/drawing/2014/main" id="{60AC1C00-59F5-FAC9-FA44-C9C5E9574B2F}"/>
+              </a:ext>
+            </a:extLst>
+          </p:cNvPr>
+          <p:cNvSpPr txBox="1"/>
+          <p:nvPr/>
+        </p:nvSpPr>
+        <p:spPr>
+          <a:xfrm>
+            <a:off x="1194667" y="2992860"/>
+            <a:ext cx="4789837" cy="369332"/>
+          </a:xfrm>
+          <a:prstGeom prst="rect">
+            <a:avLst/>
+          </a:prstGeom>
+          <a:noFill/>
+        </p:spPr>
+        <p:txBody>
+          <a:bodyPr wrap="none" rtlCol="0">
+            <a:spAutoFit/>
+          </a:bodyPr>
+          <a:lstStyle/>
+          <a:p>
+            <a:r>
+              <a:rPr lang="ru-RU" dirty="0"/>
+              <a:t>Поворотная арка из 12 ячеек (4 суперпериода)</a:t>
+            </a:r>
+          </a:p>
+        </p:txBody>
+      </p:sp>
+      <p:sp>
+        <p:nvSpPr>
+          <p:cNvPr id="84" name="Прямоугольник 83">
+            <a:extLst>
+              <a:ext uri="{FF2B5EF4-FFF2-40B4-BE49-F238E27FC236}">
+                <a16:creationId xmlns:a16="http://schemas.microsoft.com/office/drawing/2014/main" id="{F88566A7-971A-A4F9-36DE-5A6CBC61A345}"/>
+              </a:ext>
+            </a:extLst>
+          </p:cNvPr>
+          <p:cNvSpPr/>
+          <p:nvPr/>
+        </p:nvSpPr>
+        <p:spPr>
+          <a:xfrm>
+            <a:off x="6820759" y="3924670"/>
+            <a:ext cx="569938" cy="330966"/>
+          </a:xfrm>
+          <a:prstGeom prst="rect">
+            <a:avLst/>
+          </a:prstGeom>
+        </p:spPr>
+        <p:style>
+          <a:lnRef idx="2">
+            <a:schemeClr val="accent1">
+              <a:shade val="15000"/>
+            </a:schemeClr>
+          </a:lnRef>
+          <a:fillRef idx="1">
+            <a:schemeClr val="accent1"/>
+          </a:fillRef>
+          <a:effectRef idx="0">
+            <a:schemeClr val="accent1"/>
+          </a:effectRef>
+          <a:fontRef idx="minor">
+            <a:schemeClr val="lt1"/>
+          </a:fontRef>
+        </p:style>
+        <p:txBody>
+          <a:bodyPr rtlCol="0" anchor="ctr">
+            <a:scene3d>
+              <a:camera prst="orthographicFront">
+                <a:rot lat="0" lon="0" rev="0"/>
+              </a:camera>
+              <a:lightRig rig="threePt" dir="t"/>
+            </a:scene3d>
+          </a:bodyPr>
+          <a:lstStyle/>
+          <a:p>
+            <a:pPr algn="ctr"/>
+            <a:r>
+              <a:rPr lang="ru-RU" sz="1100" dirty="0"/>
+              <a:t>ФОДО</a:t>
+            </a:r>
+          </a:p>
+        </p:txBody>
+      </p:sp>
+      <p:sp>
+        <p:nvSpPr>
+          <p:cNvPr id="85" name="Прямоугольник 84">
+            <a:extLst>
+              <a:ext uri="{FF2B5EF4-FFF2-40B4-BE49-F238E27FC236}">
+                <a16:creationId xmlns:a16="http://schemas.microsoft.com/office/drawing/2014/main" id="{8A2C5896-8E2E-27AF-E157-8127C71F4FF2}"/>
+              </a:ext>
+            </a:extLst>
+          </p:cNvPr>
+          <p:cNvSpPr/>
+          <p:nvPr/>
+        </p:nvSpPr>
+        <p:spPr>
+          <a:xfrm>
+            <a:off x="7390697" y="3924812"/>
+            <a:ext cx="569938" cy="330966"/>
+          </a:xfrm>
+          <a:prstGeom prst="rect">
+            <a:avLst/>
+          </a:prstGeom>
+        </p:spPr>
+        <p:style>
+          <a:lnRef idx="2">
+            <a:schemeClr val="accent1">
+              <a:shade val="15000"/>
+            </a:schemeClr>
+          </a:lnRef>
+          <a:fillRef idx="1">
+            <a:schemeClr val="accent1"/>
+          </a:fillRef>
+          <a:effectRef idx="0">
+            <a:schemeClr val="accent1"/>
+          </a:effectRef>
+          <a:fontRef idx="minor">
+            <a:schemeClr val="lt1"/>
+          </a:fontRef>
+        </p:style>
+        <p:txBody>
+          <a:bodyPr rtlCol="0" anchor="ctr">
+            <a:scene3d>
+              <a:camera prst="orthographicFront">
+                <a:rot lat="0" lon="0" rev="0"/>
+              </a:camera>
+              <a:lightRig rig="threePt" dir="t"/>
+            </a:scene3d>
+          </a:bodyPr>
+          <a:lstStyle/>
+          <a:p>
+            <a:pPr algn="ctr"/>
+            <a:r>
+              <a:rPr lang="ru-RU" sz="1100" dirty="0"/>
+              <a:t>ФОДО</a:t>
+            </a:r>
+          </a:p>
+        </p:txBody>
+      </p:sp>
     </p:spTree>
     <p:extLst>
       <p:ext uri="{BB962C8B-B14F-4D97-AF65-F5344CB8AC3E}">
         <p14:creationId xmlns:p14="http://schemas.microsoft.com/office/powerpoint/2010/main" val="4070336987"/>
+      </p:ext>
+    </p:extLst>
+  </p:cSld>
+  <p:clrMapOvr>
+    <a:masterClrMapping/>
+  </p:clrMapOvr>
+</p:sld>
+</file>
+
+<file path=ppt/slides/slide2.xml><?xml version="1.0" encoding="utf-8"?>
+<p:sld xmlns:a="http://schemas.openxmlformats.org/drawingml/2006/main" xmlns:r="http://schemas.openxmlformats.org/officeDocument/2006/relationships" xmlns:p="http://schemas.openxmlformats.org/presentationml/2006/main">
+  <p:cSld>
+    <p:spTree>
+      <p:nvGrpSpPr>
+        <p:cNvPr id="1" name=""/>
+        <p:cNvGrpSpPr/>
+        <p:nvPr/>
+      </p:nvGrpSpPr>
+      <p:grpSpPr>
+        <a:xfrm>
+          <a:off x="0" y="0"/>
+          <a:ext cx="0" cy="0"/>
+          <a:chOff x="0" y="0"/>
+          <a:chExt cx="0" cy="0"/>
+        </a:xfrm>
+      </p:grpSpPr>
+      <p:cxnSp>
+        <p:nvCxnSpPr>
+          <p:cNvPr id="46" name="Прямая соединительная линия 45">
+            <a:extLst>
+              <a:ext uri="{FF2B5EF4-FFF2-40B4-BE49-F238E27FC236}">
+                <a16:creationId xmlns:a16="http://schemas.microsoft.com/office/drawing/2014/main" id="{2A40BA7F-64F0-3E6A-10AB-874BEC5F8496}"/>
+              </a:ext>
+            </a:extLst>
+          </p:cNvPr>
+          <p:cNvCxnSpPr>
+            <a:cxnSpLocks/>
+            <a:stCxn id="14" idx="3"/>
+          </p:cNvCxnSpPr>
+          <p:nvPr/>
+        </p:nvCxnSpPr>
+        <p:spPr>
+          <a:xfrm>
+            <a:off x="4459744" y="2685386"/>
+            <a:ext cx="0" cy="269999"/>
+          </a:xfrm>
+          <a:prstGeom prst="line">
+            <a:avLst/>
+          </a:prstGeom>
+        </p:spPr>
+        <p:style>
+          <a:lnRef idx="2">
+            <a:schemeClr val="accent2"/>
+          </a:lnRef>
+          <a:fillRef idx="0">
+            <a:schemeClr val="accent2"/>
+          </a:fillRef>
+          <a:effectRef idx="1">
+            <a:schemeClr val="accent2"/>
+          </a:effectRef>
+          <a:fontRef idx="minor">
+            <a:schemeClr val="tx1"/>
+          </a:fontRef>
+        </p:style>
+      </p:cxnSp>
+      <p:cxnSp>
+        <p:nvCxnSpPr>
+          <p:cNvPr id="21" name="Прямая соединительная линия 20">
+            <a:extLst>
+              <a:ext uri="{FF2B5EF4-FFF2-40B4-BE49-F238E27FC236}">
+                <a16:creationId xmlns:a16="http://schemas.microsoft.com/office/drawing/2014/main" id="{A41000D6-54DB-2BAA-5225-D1168D08F75C}"/>
+              </a:ext>
+            </a:extLst>
+          </p:cNvPr>
+          <p:cNvCxnSpPr>
+            <a:cxnSpLocks/>
+            <a:stCxn id="7" idx="1"/>
+          </p:cNvCxnSpPr>
+          <p:nvPr/>
+        </p:nvCxnSpPr>
+        <p:spPr>
+          <a:xfrm>
+            <a:off x="876904" y="2685385"/>
+            <a:ext cx="0" cy="270000"/>
+          </a:xfrm>
+          <a:prstGeom prst="line">
+            <a:avLst/>
+          </a:prstGeom>
+        </p:spPr>
+        <p:style>
+          <a:lnRef idx="2">
+            <a:schemeClr val="accent2"/>
+          </a:lnRef>
+          <a:fillRef idx="0">
+            <a:schemeClr val="accent2"/>
+          </a:fillRef>
+          <a:effectRef idx="1">
+            <a:schemeClr val="accent2"/>
+          </a:effectRef>
+          <a:fontRef idx="minor">
+            <a:schemeClr val="tx1"/>
+          </a:fontRef>
+        </p:style>
+      </p:cxnSp>
+      <p:cxnSp>
+        <p:nvCxnSpPr>
+          <p:cNvPr id="35" name="Прямая соединительная линия 34">
+            <a:extLst>
+              <a:ext uri="{FF2B5EF4-FFF2-40B4-BE49-F238E27FC236}">
+                <a16:creationId xmlns:a16="http://schemas.microsoft.com/office/drawing/2014/main" id="{F8209E04-E920-5F3E-9FBC-B88D81FE8181}"/>
+              </a:ext>
+            </a:extLst>
+          </p:cNvPr>
+          <p:cNvCxnSpPr>
+            <a:cxnSpLocks/>
+            <a:stCxn id="6" idx="3"/>
+          </p:cNvCxnSpPr>
+          <p:nvPr/>
+        </p:nvCxnSpPr>
+        <p:spPr>
+          <a:xfrm>
+            <a:off x="1462073" y="2685385"/>
+            <a:ext cx="0" cy="270000"/>
+          </a:xfrm>
+          <a:prstGeom prst="line">
+            <a:avLst/>
+          </a:prstGeom>
+        </p:spPr>
+        <p:style>
+          <a:lnRef idx="2">
+            <a:schemeClr val="accent2"/>
+          </a:lnRef>
+          <a:fillRef idx="0">
+            <a:schemeClr val="accent2"/>
+          </a:fillRef>
+          <a:effectRef idx="1">
+            <a:schemeClr val="accent2"/>
+          </a:effectRef>
+          <a:fontRef idx="minor">
+            <a:schemeClr val="tx1"/>
+          </a:fontRef>
+        </p:style>
+      </p:cxnSp>
+      <p:cxnSp>
+        <p:nvCxnSpPr>
+          <p:cNvPr id="43" name="Прямая соединительная линия 42">
+            <a:extLst>
+              <a:ext uri="{FF2B5EF4-FFF2-40B4-BE49-F238E27FC236}">
+                <a16:creationId xmlns:a16="http://schemas.microsoft.com/office/drawing/2014/main" id="{18987D08-AADC-E762-E766-2E72482B31D3}"/>
+              </a:ext>
+            </a:extLst>
+          </p:cNvPr>
+          <p:cNvCxnSpPr>
+            <a:cxnSpLocks/>
+            <a:stCxn id="16" idx="3"/>
+          </p:cNvCxnSpPr>
+          <p:nvPr/>
+        </p:nvCxnSpPr>
+        <p:spPr>
+          <a:xfrm>
+            <a:off x="3878086" y="2685386"/>
+            <a:ext cx="0" cy="269999"/>
+          </a:xfrm>
+          <a:prstGeom prst="line">
+            <a:avLst/>
+          </a:prstGeom>
+        </p:spPr>
+        <p:style>
+          <a:lnRef idx="2">
+            <a:schemeClr val="accent2"/>
+          </a:lnRef>
+          <a:fillRef idx="0">
+            <a:schemeClr val="accent2"/>
+          </a:fillRef>
+          <a:effectRef idx="1">
+            <a:schemeClr val="accent2"/>
+          </a:effectRef>
+          <a:fontRef idx="minor">
+            <a:schemeClr val="tx1"/>
+          </a:fontRef>
+        </p:style>
+      </p:cxnSp>
+      <p:sp>
+        <p:nvSpPr>
+          <p:cNvPr id="4" name="TextBox 3">
+            <a:extLst>
+              <a:ext uri="{FF2B5EF4-FFF2-40B4-BE49-F238E27FC236}">
+                <a16:creationId xmlns:a16="http://schemas.microsoft.com/office/drawing/2014/main" id="{642FAC07-A60E-B296-F1C0-AF887F1E6622}"/>
+              </a:ext>
+            </a:extLst>
+          </p:cNvPr>
+          <p:cNvSpPr txBox="1"/>
+          <p:nvPr/>
+        </p:nvSpPr>
+        <p:spPr>
+          <a:xfrm>
+            <a:off x="766057" y="2955385"/>
+            <a:ext cx="813824" cy="276999"/>
+          </a:xfrm>
+          <a:prstGeom prst="rect">
+            <a:avLst/>
+          </a:prstGeom>
+          <a:noFill/>
+        </p:spPr>
+        <p:txBody>
+          <a:bodyPr wrap="square">
+            <a:spAutoFit/>
+          </a:bodyPr>
+          <a:lstStyle/>
+          <a:p>
+            <a:r>
+              <a:rPr lang="en-US" sz="1200" dirty="0"/>
+              <a:t>45° 8 mag</a:t>
+            </a:r>
+            <a:endParaRPr lang="ru-RU" sz="1200" dirty="0"/>
+          </a:p>
+        </p:txBody>
+      </p:sp>
+      <p:sp>
+        <p:nvSpPr>
+          <p:cNvPr id="5" name="Прямоугольник 4">
+            <a:extLst>
+              <a:ext uri="{FF2B5EF4-FFF2-40B4-BE49-F238E27FC236}">
+                <a16:creationId xmlns:a16="http://schemas.microsoft.com/office/drawing/2014/main" id="{AD781C6D-BF6B-F3C7-F81C-30729CFFF306}"/>
+              </a:ext>
+            </a:extLst>
+          </p:cNvPr>
+          <p:cNvSpPr/>
+          <p:nvPr/>
+        </p:nvSpPr>
+        <p:spPr>
+          <a:xfrm>
+            <a:off x="1458562" y="2572966"/>
+            <a:ext cx="294340" cy="224839"/>
+          </a:xfrm>
+          <a:prstGeom prst="rect">
+            <a:avLst/>
+          </a:prstGeom>
+        </p:spPr>
+        <p:style>
+          <a:lnRef idx="2">
+            <a:schemeClr val="accent1">
+              <a:shade val="15000"/>
+            </a:schemeClr>
+          </a:lnRef>
+          <a:fillRef idx="1">
+            <a:schemeClr val="accent1"/>
+          </a:fillRef>
+          <a:effectRef idx="0">
+            <a:schemeClr val="accent1"/>
+          </a:effectRef>
+          <a:fontRef idx="minor">
+            <a:schemeClr val="lt1"/>
+          </a:fontRef>
+        </p:style>
+        <p:txBody>
+          <a:bodyPr rtlCol="0" anchor="ctr">
+            <a:scene3d>
+              <a:camera prst="orthographicFront">
+                <a:rot lat="0" lon="0" rev="0"/>
+              </a:camera>
+              <a:lightRig rig="threePt" dir="t"/>
+            </a:scene3d>
+          </a:bodyPr>
+          <a:lstStyle/>
+          <a:p>
+            <a:pPr algn="ctr"/>
+            <a:endParaRPr lang="ru-RU" dirty="0"/>
+          </a:p>
+        </p:txBody>
+      </p:sp>
+      <p:sp>
+        <p:nvSpPr>
+          <p:cNvPr id="6" name="Прямоугольник 5">
+            <a:extLst>
+              <a:ext uri="{FF2B5EF4-FFF2-40B4-BE49-F238E27FC236}">
+                <a16:creationId xmlns:a16="http://schemas.microsoft.com/office/drawing/2014/main" id="{1B3DA4E1-C57C-6721-B5BC-184A5EA48AD0}"/>
+              </a:ext>
+            </a:extLst>
+          </p:cNvPr>
+          <p:cNvSpPr/>
+          <p:nvPr/>
+        </p:nvSpPr>
+        <p:spPr>
+          <a:xfrm>
+            <a:off x="1167733" y="2572966"/>
+            <a:ext cx="294340" cy="224839"/>
+          </a:xfrm>
+          <a:prstGeom prst="rect">
+            <a:avLst/>
+          </a:prstGeom>
+        </p:spPr>
+        <p:style>
+          <a:lnRef idx="2">
+            <a:schemeClr val="accent1">
+              <a:shade val="15000"/>
+            </a:schemeClr>
+          </a:lnRef>
+          <a:fillRef idx="1">
+            <a:schemeClr val="accent1"/>
+          </a:fillRef>
+          <a:effectRef idx="0">
+            <a:schemeClr val="accent1"/>
+          </a:effectRef>
+          <a:fontRef idx="minor">
+            <a:schemeClr val="lt1"/>
+          </a:fontRef>
+        </p:style>
+        <p:txBody>
+          <a:bodyPr rtlCol="0" anchor="ctr">
+            <a:scene3d>
+              <a:camera prst="orthographicFront">
+                <a:rot lat="0" lon="0" rev="0"/>
+              </a:camera>
+              <a:lightRig rig="threePt" dir="t"/>
+            </a:scene3d>
+          </a:bodyPr>
+          <a:lstStyle/>
+          <a:p>
+            <a:pPr algn="ctr"/>
+            <a:endParaRPr lang="ru-RU" dirty="0"/>
+          </a:p>
+        </p:txBody>
+      </p:sp>
+      <p:sp>
+        <p:nvSpPr>
+          <p:cNvPr id="7" name="Прямоугольник 6">
+            <a:extLst>
+              <a:ext uri="{FF2B5EF4-FFF2-40B4-BE49-F238E27FC236}">
+                <a16:creationId xmlns:a16="http://schemas.microsoft.com/office/drawing/2014/main" id="{7CE4029B-99CF-4CBC-0D24-B5E9D0E2DC21}"/>
+              </a:ext>
+            </a:extLst>
+          </p:cNvPr>
+          <p:cNvSpPr/>
+          <p:nvPr/>
+        </p:nvSpPr>
+        <p:spPr>
+          <a:xfrm>
+            <a:off x="876904" y="2572966"/>
+            <a:ext cx="294340" cy="224839"/>
+          </a:xfrm>
+          <a:prstGeom prst="rect">
+            <a:avLst/>
+          </a:prstGeom>
+        </p:spPr>
+        <p:style>
+          <a:lnRef idx="2">
+            <a:schemeClr val="accent1">
+              <a:shade val="15000"/>
+            </a:schemeClr>
+          </a:lnRef>
+          <a:fillRef idx="1">
+            <a:schemeClr val="accent1"/>
+          </a:fillRef>
+          <a:effectRef idx="0">
+            <a:schemeClr val="accent1"/>
+          </a:effectRef>
+          <a:fontRef idx="minor">
+            <a:schemeClr val="lt1"/>
+          </a:fontRef>
+        </p:style>
+        <p:txBody>
+          <a:bodyPr rtlCol="0" anchor="ctr">
+            <a:scene3d>
+              <a:camera prst="orthographicFront">
+                <a:rot lat="0" lon="0" rev="0"/>
+              </a:camera>
+              <a:lightRig rig="threePt" dir="t"/>
+            </a:scene3d>
+          </a:bodyPr>
+          <a:lstStyle/>
+          <a:p>
+            <a:pPr algn="ctr"/>
+            <a:endParaRPr lang="ru-RU" dirty="0"/>
+          </a:p>
+        </p:txBody>
+      </p:sp>
+      <p:sp>
+        <p:nvSpPr>
+          <p:cNvPr id="8" name="Прямоугольник 7">
+            <a:extLst>
+              <a:ext uri="{FF2B5EF4-FFF2-40B4-BE49-F238E27FC236}">
+                <a16:creationId xmlns:a16="http://schemas.microsoft.com/office/drawing/2014/main" id="{21C1AE1B-D7E4-C6EA-FA7F-3BEA68B1947E}"/>
+              </a:ext>
+            </a:extLst>
+          </p:cNvPr>
+          <p:cNvSpPr/>
+          <p:nvPr/>
+        </p:nvSpPr>
+        <p:spPr>
+          <a:xfrm>
+            <a:off x="2357087" y="2572966"/>
+            <a:ext cx="294340" cy="224839"/>
+          </a:xfrm>
+          <a:prstGeom prst="rect">
+            <a:avLst/>
+          </a:prstGeom>
+        </p:spPr>
+        <p:style>
+          <a:lnRef idx="2">
+            <a:schemeClr val="accent1">
+              <a:shade val="15000"/>
+            </a:schemeClr>
+          </a:lnRef>
+          <a:fillRef idx="1">
+            <a:schemeClr val="accent1"/>
+          </a:fillRef>
+          <a:effectRef idx="0">
+            <a:schemeClr val="accent1"/>
+          </a:effectRef>
+          <a:fontRef idx="minor">
+            <a:schemeClr val="lt1"/>
+          </a:fontRef>
+        </p:style>
+        <p:txBody>
+          <a:bodyPr rtlCol="0" anchor="ctr">
+            <a:scene3d>
+              <a:camera prst="orthographicFront">
+                <a:rot lat="0" lon="0" rev="0"/>
+              </a:camera>
+              <a:lightRig rig="threePt" dir="t"/>
+            </a:scene3d>
+          </a:bodyPr>
+          <a:lstStyle/>
+          <a:p>
+            <a:pPr algn="ctr"/>
+            <a:endParaRPr lang="ru-RU" dirty="0"/>
+          </a:p>
+        </p:txBody>
+      </p:sp>
+      <p:sp>
+        <p:nvSpPr>
+          <p:cNvPr id="9" name="Прямоугольник 8">
+            <a:extLst>
+              <a:ext uri="{FF2B5EF4-FFF2-40B4-BE49-F238E27FC236}">
+                <a16:creationId xmlns:a16="http://schemas.microsoft.com/office/drawing/2014/main" id="{A4C77AC9-B87E-4A67-7EE0-0E76F57DBAB3}"/>
+              </a:ext>
+            </a:extLst>
+          </p:cNvPr>
+          <p:cNvSpPr/>
+          <p:nvPr/>
+        </p:nvSpPr>
+        <p:spPr>
+          <a:xfrm>
+            <a:off x="2066258" y="2572966"/>
+            <a:ext cx="294340" cy="224839"/>
+          </a:xfrm>
+          <a:prstGeom prst="rect">
+            <a:avLst/>
+          </a:prstGeom>
+        </p:spPr>
+        <p:style>
+          <a:lnRef idx="2">
+            <a:schemeClr val="accent1">
+              <a:shade val="15000"/>
+            </a:schemeClr>
+          </a:lnRef>
+          <a:fillRef idx="1">
+            <a:schemeClr val="accent1"/>
+          </a:fillRef>
+          <a:effectRef idx="0">
+            <a:schemeClr val="accent1"/>
+          </a:effectRef>
+          <a:fontRef idx="minor">
+            <a:schemeClr val="lt1"/>
+          </a:fontRef>
+        </p:style>
+        <p:txBody>
+          <a:bodyPr rtlCol="0" anchor="ctr">
+            <a:scene3d>
+              <a:camera prst="orthographicFront">
+                <a:rot lat="0" lon="0" rev="0"/>
+              </a:camera>
+              <a:lightRig rig="threePt" dir="t"/>
+            </a:scene3d>
+          </a:bodyPr>
+          <a:lstStyle/>
+          <a:p>
+            <a:pPr algn="ctr"/>
+            <a:endParaRPr lang="ru-RU" dirty="0"/>
+          </a:p>
+        </p:txBody>
+      </p:sp>
+      <p:sp>
+        <p:nvSpPr>
+          <p:cNvPr id="10" name="Прямоугольник 9">
+            <a:extLst>
+              <a:ext uri="{FF2B5EF4-FFF2-40B4-BE49-F238E27FC236}">
+                <a16:creationId xmlns:a16="http://schemas.microsoft.com/office/drawing/2014/main" id="{4AA51857-49F5-D282-3304-11BBEB9266E9}"/>
+              </a:ext>
+            </a:extLst>
+          </p:cNvPr>
+          <p:cNvSpPr/>
+          <p:nvPr/>
+        </p:nvSpPr>
+        <p:spPr>
+          <a:xfrm>
+            <a:off x="1775429" y="2572966"/>
+            <a:ext cx="294340" cy="224839"/>
+          </a:xfrm>
+          <a:prstGeom prst="rect">
+            <a:avLst/>
+          </a:prstGeom>
+        </p:spPr>
+        <p:style>
+          <a:lnRef idx="2">
+            <a:schemeClr val="accent1">
+              <a:shade val="15000"/>
+            </a:schemeClr>
+          </a:lnRef>
+          <a:fillRef idx="1">
+            <a:schemeClr val="accent1"/>
+          </a:fillRef>
+          <a:effectRef idx="0">
+            <a:schemeClr val="accent1"/>
+          </a:effectRef>
+          <a:fontRef idx="minor">
+            <a:schemeClr val="lt1"/>
+          </a:fontRef>
+        </p:style>
+        <p:txBody>
+          <a:bodyPr rtlCol="0" anchor="ctr">
+            <a:scene3d>
+              <a:camera prst="orthographicFront">
+                <a:rot lat="0" lon="0" rev="0"/>
+              </a:camera>
+              <a:lightRig rig="threePt" dir="t"/>
+            </a:scene3d>
+          </a:bodyPr>
+          <a:lstStyle/>
+          <a:p>
+            <a:pPr algn="ctr"/>
+            <a:endParaRPr lang="ru-RU" dirty="0"/>
+          </a:p>
+        </p:txBody>
+      </p:sp>
+      <p:sp>
+        <p:nvSpPr>
+          <p:cNvPr id="11" name="Прямоугольник 10">
+            <a:extLst>
+              <a:ext uri="{FF2B5EF4-FFF2-40B4-BE49-F238E27FC236}">
+                <a16:creationId xmlns:a16="http://schemas.microsoft.com/office/drawing/2014/main" id="{7519232A-1B0F-29DB-F3DA-DB630C33B7AB}"/>
+              </a:ext>
+            </a:extLst>
+          </p:cNvPr>
+          <p:cNvSpPr/>
+          <p:nvPr/>
+        </p:nvSpPr>
+        <p:spPr>
+          <a:xfrm>
+            <a:off x="3261245" y="2572966"/>
+            <a:ext cx="294340" cy="224839"/>
+          </a:xfrm>
+          <a:prstGeom prst="rect">
+            <a:avLst/>
+          </a:prstGeom>
+        </p:spPr>
+        <p:style>
+          <a:lnRef idx="2">
+            <a:schemeClr val="accent1">
+              <a:shade val="15000"/>
+            </a:schemeClr>
+          </a:lnRef>
+          <a:fillRef idx="1">
+            <a:schemeClr val="accent1"/>
+          </a:fillRef>
+          <a:effectRef idx="0">
+            <a:schemeClr val="accent1"/>
+          </a:effectRef>
+          <a:fontRef idx="minor">
+            <a:schemeClr val="lt1"/>
+          </a:fontRef>
+        </p:style>
+        <p:txBody>
+          <a:bodyPr rtlCol="0" anchor="ctr">
+            <a:scene3d>
+              <a:camera prst="orthographicFront">
+                <a:rot lat="0" lon="0" rev="0"/>
+              </a:camera>
+              <a:lightRig rig="threePt" dir="t"/>
+            </a:scene3d>
+          </a:bodyPr>
+          <a:lstStyle/>
+          <a:p>
+            <a:pPr algn="ctr"/>
+            <a:endParaRPr lang="ru-RU" dirty="0"/>
+          </a:p>
+        </p:txBody>
+      </p:sp>
+      <p:sp>
+        <p:nvSpPr>
+          <p:cNvPr id="12" name="Прямоугольник 11">
+            <a:extLst>
+              <a:ext uri="{FF2B5EF4-FFF2-40B4-BE49-F238E27FC236}">
+                <a16:creationId xmlns:a16="http://schemas.microsoft.com/office/drawing/2014/main" id="{F2A36EF0-68BE-37FB-123D-2DE04D7595A4}"/>
+              </a:ext>
+            </a:extLst>
+          </p:cNvPr>
+          <p:cNvSpPr/>
+          <p:nvPr/>
+        </p:nvSpPr>
+        <p:spPr>
+          <a:xfrm>
+            <a:off x="2970416" y="2572966"/>
+            <a:ext cx="294340" cy="224839"/>
+          </a:xfrm>
+          <a:prstGeom prst="rect">
+            <a:avLst/>
+          </a:prstGeom>
+        </p:spPr>
+        <p:style>
+          <a:lnRef idx="2">
+            <a:schemeClr val="accent1">
+              <a:shade val="15000"/>
+            </a:schemeClr>
+          </a:lnRef>
+          <a:fillRef idx="1">
+            <a:schemeClr val="accent1"/>
+          </a:fillRef>
+          <a:effectRef idx="0">
+            <a:schemeClr val="accent1"/>
+          </a:effectRef>
+          <a:fontRef idx="minor">
+            <a:schemeClr val="lt1"/>
+          </a:fontRef>
+        </p:style>
+        <p:txBody>
+          <a:bodyPr rtlCol="0" anchor="ctr">
+            <a:scene3d>
+              <a:camera prst="orthographicFront">
+                <a:rot lat="0" lon="0" rev="0"/>
+              </a:camera>
+              <a:lightRig rig="threePt" dir="t"/>
+            </a:scene3d>
+          </a:bodyPr>
+          <a:lstStyle/>
+          <a:p>
+            <a:pPr algn="ctr"/>
+            <a:endParaRPr lang="ru-RU" dirty="0"/>
+          </a:p>
+        </p:txBody>
+      </p:sp>
+      <p:sp>
+        <p:nvSpPr>
+          <p:cNvPr id="13" name="Прямоугольник 12">
+            <a:extLst>
+              <a:ext uri="{FF2B5EF4-FFF2-40B4-BE49-F238E27FC236}">
+                <a16:creationId xmlns:a16="http://schemas.microsoft.com/office/drawing/2014/main" id="{9BF764D6-BBC6-D05A-C94D-83FCFC3A3612}"/>
+              </a:ext>
+            </a:extLst>
+          </p:cNvPr>
+          <p:cNvSpPr/>
+          <p:nvPr/>
+        </p:nvSpPr>
+        <p:spPr>
+          <a:xfrm>
+            <a:off x="2679587" y="2572966"/>
+            <a:ext cx="294340" cy="224839"/>
+          </a:xfrm>
+          <a:prstGeom prst="rect">
+            <a:avLst/>
+          </a:prstGeom>
+        </p:spPr>
+        <p:style>
+          <a:lnRef idx="2">
+            <a:schemeClr val="accent1">
+              <a:shade val="15000"/>
+            </a:schemeClr>
+          </a:lnRef>
+          <a:fillRef idx="1">
+            <a:schemeClr val="accent1"/>
+          </a:fillRef>
+          <a:effectRef idx="0">
+            <a:schemeClr val="accent1"/>
+          </a:effectRef>
+          <a:fontRef idx="minor">
+            <a:schemeClr val="lt1"/>
+          </a:fontRef>
+        </p:style>
+        <p:txBody>
+          <a:bodyPr rtlCol="0" anchor="ctr">
+            <a:scene3d>
+              <a:camera prst="orthographicFront">
+                <a:rot lat="0" lon="0" rev="0"/>
+              </a:camera>
+              <a:lightRig rig="threePt" dir="t"/>
+            </a:scene3d>
+          </a:bodyPr>
+          <a:lstStyle/>
+          <a:p>
+            <a:pPr algn="ctr"/>
+            <a:endParaRPr lang="ru-RU" dirty="0"/>
+          </a:p>
+        </p:txBody>
+      </p:sp>
+      <p:sp>
+        <p:nvSpPr>
+          <p:cNvPr id="14" name="Прямоугольник 13">
+            <a:extLst>
+              <a:ext uri="{FF2B5EF4-FFF2-40B4-BE49-F238E27FC236}">
+                <a16:creationId xmlns:a16="http://schemas.microsoft.com/office/drawing/2014/main" id="{6A45D9C4-D66D-3AD3-E674-7B35033EFEF2}"/>
+              </a:ext>
+            </a:extLst>
+          </p:cNvPr>
+          <p:cNvSpPr/>
+          <p:nvPr/>
+        </p:nvSpPr>
+        <p:spPr>
+          <a:xfrm>
+            <a:off x="4165404" y="2572966"/>
+            <a:ext cx="294340" cy="224839"/>
+          </a:xfrm>
+          <a:prstGeom prst="rect">
+            <a:avLst/>
+          </a:prstGeom>
+        </p:spPr>
+        <p:style>
+          <a:lnRef idx="2">
+            <a:schemeClr val="accent1">
+              <a:shade val="15000"/>
+            </a:schemeClr>
+          </a:lnRef>
+          <a:fillRef idx="1">
+            <a:schemeClr val="accent1"/>
+          </a:fillRef>
+          <a:effectRef idx="0">
+            <a:schemeClr val="accent1"/>
+          </a:effectRef>
+          <a:fontRef idx="minor">
+            <a:schemeClr val="lt1"/>
+          </a:fontRef>
+        </p:style>
+        <p:txBody>
+          <a:bodyPr rtlCol="0" anchor="ctr">
+            <a:scene3d>
+              <a:camera prst="orthographicFront">
+                <a:rot lat="0" lon="0" rev="0"/>
+              </a:camera>
+              <a:lightRig rig="threePt" dir="t"/>
+            </a:scene3d>
+          </a:bodyPr>
+          <a:lstStyle/>
+          <a:p>
+            <a:pPr algn="ctr"/>
+            <a:endParaRPr lang="ru-RU" dirty="0"/>
+          </a:p>
+        </p:txBody>
+      </p:sp>
+      <p:sp>
+        <p:nvSpPr>
+          <p:cNvPr id="15" name="Прямоугольник 14">
+            <a:extLst>
+              <a:ext uri="{FF2B5EF4-FFF2-40B4-BE49-F238E27FC236}">
+                <a16:creationId xmlns:a16="http://schemas.microsoft.com/office/drawing/2014/main" id="{0F5F0457-E979-34E8-9332-BF1389AAF0AD}"/>
+              </a:ext>
+            </a:extLst>
+          </p:cNvPr>
+          <p:cNvSpPr/>
+          <p:nvPr/>
+        </p:nvSpPr>
+        <p:spPr>
+          <a:xfrm>
+            <a:off x="3874575" y="2572966"/>
+            <a:ext cx="294340" cy="224839"/>
+          </a:xfrm>
+          <a:prstGeom prst="rect">
+            <a:avLst/>
+          </a:prstGeom>
+        </p:spPr>
+        <p:style>
+          <a:lnRef idx="2">
+            <a:schemeClr val="accent1">
+              <a:shade val="15000"/>
+            </a:schemeClr>
+          </a:lnRef>
+          <a:fillRef idx="1">
+            <a:schemeClr val="accent1"/>
+          </a:fillRef>
+          <a:effectRef idx="0">
+            <a:schemeClr val="accent1"/>
+          </a:effectRef>
+          <a:fontRef idx="minor">
+            <a:schemeClr val="lt1"/>
+          </a:fontRef>
+        </p:style>
+        <p:txBody>
+          <a:bodyPr rtlCol="0" anchor="ctr">
+            <a:scene3d>
+              <a:camera prst="orthographicFront">
+                <a:rot lat="0" lon="0" rev="0"/>
+              </a:camera>
+              <a:lightRig rig="threePt" dir="t"/>
+            </a:scene3d>
+          </a:bodyPr>
+          <a:lstStyle/>
+          <a:p>
+            <a:pPr algn="ctr"/>
+            <a:endParaRPr lang="ru-RU" dirty="0"/>
+          </a:p>
+        </p:txBody>
+      </p:sp>
+      <p:sp>
+        <p:nvSpPr>
+          <p:cNvPr id="16" name="Прямоугольник 15">
+            <a:extLst>
+              <a:ext uri="{FF2B5EF4-FFF2-40B4-BE49-F238E27FC236}">
+                <a16:creationId xmlns:a16="http://schemas.microsoft.com/office/drawing/2014/main" id="{2C23D223-1059-9295-C5BC-7DA68BEFBA44}"/>
+              </a:ext>
+            </a:extLst>
+          </p:cNvPr>
+          <p:cNvSpPr/>
+          <p:nvPr/>
+        </p:nvSpPr>
+        <p:spPr>
+          <a:xfrm>
+            <a:off x="3583746" y="2572966"/>
+            <a:ext cx="294340" cy="224839"/>
+          </a:xfrm>
+          <a:prstGeom prst="rect">
+            <a:avLst/>
+          </a:prstGeom>
+        </p:spPr>
+        <p:style>
+          <a:lnRef idx="2">
+            <a:schemeClr val="accent1">
+              <a:shade val="15000"/>
+            </a:schemeClr>
+          </a:lnRef>
+          <a:fillRef idx="1">
+            <a:schemeClr val="accent1"/>
+          </a:fillRef>
+          <a:effectRef idx="0">
+            <a:schemeClr val="accent1"/>
+          </a:effectRef>
+          <a:fontRef idx="minor">
+            <a:schemeClr val="lt1"/>
+          </a:fontRef>
+        </p:style>
+        <p:txBody>
+          <a:bodyPr rtlCol="0" anchor="ctr">
+            <a:scene3d>
+              <a:camera prst="orthographicFront">
+                <a:rot lat="0" lon="0" rev="0"/>
+              </a:camera>
+              <a:lightRig rig="threePt" dir="t"/>
+            </a:scene3d>
+          </a:bodyPr>
+          <a:lstStyle/>
+          <a:p>
+            <a:pPr algn="ctr"/>
+            <a:endParaRPr lang="ru-RU" dirty="0"/>
+          </a:p>
+        </p:txBody>
+      </p:sp>
+      <p:cxnSp>
+        <p:nvCxnSpPr>
+          <p:cNvPr id="19" name="Прямая со стрелкой 18">
+            <a:extLst>
+              <a:ext uri="{FF2B5EF4-FFF2-40B4-BE49-F238E27FC236}">
+                <a16:creationId xmlns:a16="http://schemas.microsoft.com/office/drawing/2014/main" id="{F435DED6-7B4C-3E85-4D3B-08209A2C453B}"/>
+              </a:ext>
+            </a:extLst>
+          </p:cNvPr>
+          <p:cNvCxnSpPr>
+            <a:cxnSpLocks/>
+          </p:cNvCxnSpPr>
+          <p:nvPr/>
+        </p:nvCxnSpPr>
+        <p:spPr>
+          <a:xfrm>
+            <a:off x="876904" y="2955385"/>
+            <a:ext cx="581658" cy="0"/>
+          </a:xfrm>
+          <a:prstGeom prst="straightConnector1">
+            <a:avLst/>
+          </a:prstGeom>
+          <a:ln>
+            <a:headEnd type="triangle"/>
+            <a:tailEnd type="triangle"/>
+          </a:ln>
+        </p:spPr>
+        <p:style>
+          <a:lnRef idx="2">
+            <a:schemeClr val="accent2"/>
+          </a:lnRef>
+          <a:fillRef idx="0">
+            <a:schemeClr val="accent2"/>
+          </a:fillRef>
+          <a:effectRef idx="1">
+            <a:schemeClr val="accent2"/>
+          </a:effectRef>
+          <a:fontRef idx="minor">
+            <a:schemeClr val="tx1"/>
+          </a:fontRef>
+        </p:style>
+      </p:cxnSp>
+      <p:sp>
+        <p:nvSpPr>
+          <p:cNvPr id="20" name="TextBox 19">
+            <a:extLst>
+              <a:ext uri="{FF2B5EF4-FFF2-40B4-BE49-F238E27FC236}">
+                <a16:creationId xmlns:a16="http://schemas.microsoft.com/office/drawing/2014/main" id="{4189BC67-01C8-8553-2E3F-D95ADDB9B02D}"/>
+              </a:ext>
+            </a:extLst>
+          </p:cNvPr>
+          <p:cNvSpPr txBox="1"/>
+          <p:nvPr/>
+        </p:nvSpPr>
+        <p:spPr>
+          <a:xfrm>
+            <a:off x="2179744" y="2955382"/>
+            <a:ext cx="970137" cy="276999"/>
+          </a:xfrm>
+          <a:prstGeom prst="rect">
+            <a:avLst/>
+          </a:prstGeom>
+          <a:noFill/>
+        </p:spPr>
+        <p:txBody>
+          <a:bodyPr wrap="none" rtlCol="0">
+            <a:spAutoFit/>
+          </a:bodyPr>
+          <a:lstStyle/>
+          <a:p>
+            <a:r>
+              <a:rPr lang="en-US" sz="1200" dirty="0"/>
+              <a:t>180° 32mag </a:t>
+            </a:r>
+            <a:endParaRPr lang="ru-RU" sz="1200" dirty="0"/>
+          </a:p>
+        </p:txBody>
+      </p:sp>
+      <p:cxnSp>
+        <p:nvCxnSpPr>
+          <p:cNvPr id="49" name="Прямая со стрелкой 48">
+            <a:extLst>
+              <a:ext uri="{FF2B5EF4-FFF2-40B4-BE49-F238E27FC236}">
+                <a16:creationId xmlns:a16="http://schemas.microsoft.com/office/drawing/2014/main" id="{98A7ED64-F114-BAAA-8A64-6055EE8CBE85}"/>
+              </a:ext>
+            </a:extLst>
+          </p:cNvPr>
+          <p:cNvCxnSpPr>
+            <a:cxnSpLocks/>
+          </p:cNvCxnSpPr>
+          <p:nvPr/>
+        </p:nvCxnSpPr>
+        <p:spPr>
+          <a:xfrm>
+            <a:off x="3881598" y="2955385"/>
+            <a:ext cx="578146" cy="0"/>
+          </a:xfrm>
+          <a:prstGeom prst="straightConnector1">
+            <a:avLst/>
+          </a:prstGeom>
+          <a:ln>
+            <a:headEnd type="triangle"/>
+            <a:tailEnd type="triangle"/>
+          </a:ln>
+        </p:spPr>
+        <p:style>
+          <a:lnRef idx="2">
+            <a:schemeClr val="accent2"/>
+          </a:lnRef>
+          <a:fillRef idx="0">
+            <a:schemeClr val="accent2"/>
+          </a:fillRef>
+          <a:effectRef idx="1">
+            <a:schemeClr val="accent2"/>
+          </a:effectRef>
+          <a:fontRef idx="minor">
+            <a:schemeClr val="tx1"/>
+          </a:fontRef>
+        </p:style>
+      </p:cxnSp>
+      <p:cxnSp>
+        <p:nvCxnSpPr>
+          <p:cNvPr id="52" name="Прямая со стрелкой 51">
+            <a:extLst>
+              <a:ext uri="{FF2B5EF4-FFF2-40B4-BE49-F238E27FC236}">
+                <a16:creationId xmlns:a16="http://schemas.microsoft.com/office/drawing/2014/main" id="{622DC768-4E2A-FADF-2F88-3F3EF8D561EE}"/>
+              </a:ext>
+            </a:extLst>
+          </p:cNvPr>
+          <p:cNvCxnSpPr>
+            <a:cxnSpLocks/>
+          </p:cNvCxnSpPr>
+          <p:nvPr/>
+        </p:nvCxnSpPr>
+        <p:spPr>
+          <a:xfrm>
+            <a:off x="1462072" y="2955385"/>
+            <a:ext cx="2412503" cy="0"/>
+          </a:xfrm>
+          <a:prstGeom prst="straightConnector1">
+            <a:avLst/>
+          </a:prstGeom>
+          <a:ln>
+            <a:headEnd type="triangle"/>
+            <a:tailEnd type="triangle"/>
+          </a:ln>
+        </p:spPr>
+        <p:style>
+          <a:lnRef idx="2">
+            <a:schemeClr val="accent2"/>
+          </a:lnRef>
+          <a:fillRef idx="0">
+            <a:schemeClr val="accent2"/>
+          </a:fillRef>
+          <a:effectRef idx="1">
+            <a:schemeClr val="accent2"/>
+          </a:effectRef>
+          <a:fontRef idx="minor">
+            <a:schemeClr val="tx1"/>
+          </a:fontRef>
+        </p:style>
+      </p:cxnSp>
+      <p:sp>
+        <p:nvSpPr>
+          <p:cNvPr id="56" name="TextBox 55">
+            <a:extLst>
+              <a:ext uri="{FF2B5EF4-FFF2-40B4-BE49-F238E27FC236}">
+                <a16:creationId xmlns:a16="http://schemas.microsoft.com/office/drawing/2014/main" id="{83A96B1C-45F2-02D7-23F8-A5EFA3A814E9}"/>
+              </a:ext>
+            </a:extLst>
+          </p:cNvPr>
+          <p:cNvSpPr txBox="1"/>
+          <p:nvPr/>
+        </p:nvSpPr>
+        <p:spPr>
+          <a:xfrm>
+            <a:off x="3753395" y="2955383"/>
+            <a:ext cx="824018" cy="276999"/>
+          </a:xfrm>
+          <a:prstGeom prst="rect">
+            <a:avLst/>
+          </a:prstGeom>
+          <a:noFill/>
+        </p:spPr>
+        <p:txBody>
+          <a:bodyPr wrap="square">
+            <a:spAutoFit/>
+          </a:bodyPr>
+          <a:lstStyle/>
+          <a:p>
+            <a:r>
+              <a:rPr lang="en-US" sz="1200" dirty="0"/>
+              <a:t>45° 8 mag</a:t>
+            </a:r>
+            <a:endParaRPr lang="ru-RU" sz="1200" dirty="0"/>
+          </a:p>
+        </p:txBody>
+      </p:sp>
+    </p:spTree>
+    <p:extLst>
+      <p:ext uri="{BB962C8B-B14F-4D97-AF65-F5344CB8AC3E}">
+        <p14:creationId xmlns:p14="http://schemas.microsoft.com/office/powerpoint/2010/main" val="1692920846"/>
       </p:ext>
     </p:extLst>
   </p:cSld>

</xml_diff>